<commit_message>
chore: update copyright holder to Harbinger across documentation and code files
</commit_message>
<xml_diff>
--- a/docs/SkillPath-Presentation.pptx
+++ b/docs/SkillPath-Presentation.pptx
@@ -5133,7 +5133,7 @@
                 </a:solidFill>
                 <a:latin typeface="Calibri"/>
               </a:rPr>
-              <a:t>Designed &amp; developed by Sohel Pathan  ·  © 2026 Sohel Pathan. All rights reserved.</a:t>
+              <a:t>Designed &amp; developed by Harbinger  ·  © 2026 Harbinger. All rights reserved.</a:t>
             </a:r>
           </a:p>
         </p:txBody>
@@ -12333,7 +12333,7 @@
                 </a:solidFill>
                 <a:latin typeface="Calibri"/>
               </a:rPr>
-              <a:t>Designed &amp; developed by Sohel Pathan  ·  © 2026 Sohel Pathan. All rights reserved.</a:t>
+              <a:t>Designed &amp; developed by Harbinger  ·  © 2026 Harbinger. All rights reserved.</a:t>
             </a:r>
           </a:p>
         </p:txBody>

</xml_diff>

<commit_message>
Refactor user guide and improve app installation instructions; update UI components for better layout and usability; enhance AI integration and data handling; add new features for progress tracking and resource management.
</commit_message>
<xml_diff>
--- a/docs/SkillPath-Presentation.pptx
+++ b/docs/SkillPath-Presentation.pptx
@@ -518,7 +518,7 @@
           <a:lstStyle/>
           <a:p>
             <a:r>
-              <a:t>Opening: SkillPath is an AI learning coach. Most training starts by guessing what you know. This starts by measuring it, then teaches only the gaps. There is no backend to host: it runs in the browser and installs on a phone or laptop like an app. It works with whichever AI provider you already pay for - or Google Gemini's free tier, which is the default.</a:t>
+              <a:t>Opening: SkillPath is an AI learning coach. Most training starts by guessing what you know. This starts by measuring it, then teaches only the gaps. It runs entirely in a browser tab, with no backend to host, and works with whichever AI provider you already pay for - or Google Gemini's free tier, which is the default.</a:t>
             </a:r>
           </a:p>
         </p:txBody>
@@ -728,7 +728,7 @@
           <a:lstStyle/>
           <a:p>
             <a:r>
-              <a:t>Deliberately boring architecture: a static site, a service worker for offline use, and the provider's API. It deploys anywhere, costs nothing to host, and has two clearly marked seams for the next stage - storage, and an optional key proxy.</a:t>
+              <a:t>Deliberately boring architecture: a static site plus the provider's API. It deploys anywhere, costs nothing to host, and has two clearly marked seams for the next stage - storage, and an optional key proxy.</a:t>
             </a:r>
           </a:p>
         </p:txBody>
@@ -938,7 +938,7 @@
           <a:lstStyle/>
           <a:p>
             <a:r>
-              <a:t>Close the technical story with direction. The installable, encrypted version is done. Publishing is next and small: static hosting on Vercel, and PWABuilder turns the same site into an Android package. The key proxy only matters if we want people to learn without a key of their own.</a:t>
+              <a:t>Close the technical story with direction. Encrypted keys and backups are done. Publishing is next and small: static hosting on Vercel. The key proxy only matters if we want people to learn without a key of their own.</a:t>
             </a:r>
           </a:p>
         </p:txBody>
@@ -1078,7 +1078,7 @@
           <a:lstStyle/>
           <a:p>
             <a:r>
-              <a:t>This is what turned a personal tool into something we can hand out. SkillPath is now a Progressive Web App: people install it from the browser, it opens offline, and it updates itself. Each learner uses their own key - Gemini's is free - and it is encrypted on their device with a key the app can use but never read out. Backups are a single file, so nothing is lost when someone changes phone.</a:t>
+              <a:t>This is what makes it safe to hand out. Each learner uses their own key - Gemini's is free - and it is encrypted on their device with a key the app can use but never read out. Nothing secret is ever built into the app. Backups are a single file, so nothing is lost when someone changes computer.</a:t>
             </a:r>
           </a:p>
         </p:txBody>
@@ -5067,7 +5067,7 @@
                 </a:solidFill>
                 <a:latin typeface="Calibri"/>
               </a:rPr>
-              <a:t>Installs as an app</a:t>
+              <a:t>Runs in a browser tab</a:t>
             </a:r>
           </a:p>
         </p:txBody>
@@ -7131,7 +7131,7 @@
                 </a:solidFill>
                 <a:latin typeface="Calibri"/>
               </a:rPr>
-              <a:t>No backend, no database, no account - and it installs as an app</a:t>
+              <a:t>No backend, no database, no account</a:t>
             </a:r>
           </a:p>
         </p:txBody>
@@ -8076,7 +8076,7 @@
                 </a:solidFill>
                 <a:latin typeface="Cambria"/>
               </a:rPr>
-              <a:t>Private, installable, offline</a:t>
+              <a:t>Private by design</a:t>
             </a:r>
           </a:p>
         </p:txBody>
@@ -8118,7 +8118,7 @@
                 </a:solidFill>
                 <a:latin typeface="Calibri"/>
               </a:rPr>
-              <a:t>One codebase for the web, Android and iPhone - no app store needed</a:t>
+              <a:t>Your data and your API key stay on your device</a:t>
             </a:r>
           </a:p>
         </p:txBody>
@@ -8204,7 +8204,7 @@
                 </a:solidFill>
                 <a:latin typeface="Cambria"/>
               </a:rPr>
-              <a:t>Installs like an app</a:t>
+              <a:t>Your key, encrypted</a:t>
             </a:r>
           </a:p>
         </p:txBody>
@@ -8246,7 +8246,7 @@
                 </a:solidFill>
                 <a:latin typeface="Calibri"/>
               </a:rPr>
-              <a:t>Install app in Chrome or Edge, Add to Home Screen on iPhone - own icon and window.</a:t>
+              <a:t>AES-GCM with a non-extractable device key; decrypted only in memory.</a:t>
             </a:r>
           </a:p>
         </p:txBody>
@@ -8332,7 +8332,7 @@
                 </a:solidFill>
                 <a:latin typeface="Cambria"/>
               </a:rPr>
-              <a:t>Works offline</a:t>
+              <a:t>No keys in the build</a:t>
             </a:r>
           </a:p>
         </p:txBody>
@@ -8374,7 +8374,7 @@
                 </a:solidFill>
                 <a:latin typeface="Calibri"/>
               </a:rPr>
-              <a:t>A service worker caches the app, so saved tracks open with no connection.</a:t>
+              <a:t>.env keys are for local development only - a deployed app never contains one.</a:t>
             </a:r>
           </a:p>
         </p:txBody>
@@ -8460,7 +8460,7 @@
                 </a:solidFill>
                 <a:latin typeface="Cambria"/>
               </a:rPr>
-              <a:t>Your key, encrypted</a:t>
+              <a:t>Back up and restore</a:t>
             </a:r>
           </a:p>
         </p:txBody>
@@ -8502,7 +8502,7 @@
                 </a:solidFill>
                 <a:latin typeface="Calibri"/>
               </a:rPr>
-              <a:t>AES-GCM with a non-extractable device key; decrypted only in memory.</a:t>
+              <a:t>Every track in one JSON file, checked on restore. API keys are never included.</a:t>
             </a:r>
           </a:p>
         </p:txBody>
@@ -8588,7 +8588,7 @@
                 </a:solidFill>
                 <a:latin typeface="Cambria"/>
               </a:rPr>
-              <a:t>No keys in the build</a:t>
+              <a:t>Gemini by default</a:t>
             </a:r>
           </a:p>
         </p:txBody>
@@ -8630,7 +8630,7 @@
                 </a:solidFill>
                 <a:latin typeface="Calibri"/>
               </a:rPr>
-              <a:t>.env keys are for local development only - a deployed app never contains one.</a:t>
+              <a:t>A free key in a minute, no credit card. Switch to another provider any time.</a:t>
             </a:r>
           </a:p>
         </p:txBody>
@@ -8716,7 +8716,7 @@
                 </a:solidFill>
                 <a:latin typeface="Cambria"/>
               </a:rPr>
-              <a:t>Back up and restore</a:t>
+              <a:t>Help built in</a:t>
             </a:r>
           </a:p>
         </p:txBody>
@@ -8758,7 +8758,7 @@
                 </a:solidFill>
                 <a:latin typeface="Calibri"/>
               </a:rPr>
-              <a:t>Every track in one JSON file, checked on restore. API keys are never included.</a:t>
+              <a:t>How to use, About, and Disclaimer &amp; privacy, one tap away in the menu.</a:t>
             </a:r>
           </a:p>
         </p:txBody>
@@ -8844,7 +8844,7 @@
                 </a:solidFill>
                 <a:latin typeface="Cambria"/>
               </a:rPr>
-              <a:t>Updates itself</a:t>
+              <a:t>No account, no server</a:t>
             </a:r>
           </a:p>
         </p:txBody>
@@ -8886,7 +8886,7 @@
                 </a:solidFill>
                 <a:latin typeface="Calibri"/>
               </a:rPr>
-              <a:t>A new deploy shows "New version ready - Reload" - nobody is stuck on an old copy.</a:t>
+              <a:t>Tracks stay in this browser; text goes only to the chosen AI provider.</a:t>
             </a:r>
           </a:p>
         </p:txBody>
@@ -9118,7 +9118,7 @@
                 </a:solidFill>
                 <a:latin typeface="Cambria"/>
               </a:rPr>
-              <a:t>~5,400</a:t>
+              <a:t>~5,200</a:t>
             </a:r>
           </a:p>
         </p:txBody>
@@ -9246,7 +9246,7 @@
                 </a:solidFill>
                 <a:latin typeface="Cambria"/>
               </a:rPr>
-              <a:t>48</a:t>
+              <a:t>45</a:t>
             </a:r>
           </a:p>
         </p:txBody>
@@ -9843,25 +9843,6 @@
               <a:t>IndexedDB via idb; Web Crypto for the API key</a:t>
             </a:r>
           </a:p>
-          <a:p>
-            <a:pPr algn="l">
-              <a:lnSpc>
-                <a:spcPct val="115000"/>
-              </a:lnSpc>
-              <a:spcAft>
-                <a:spcPts val="600"/>
-              </a:spcAft>
-            </a:pPr>
-            <a:r>
-              <a:rPr sz="1250" b="0">
-                <a:solidFill>
-                  <a:srgbClr val="475569"/>
-                </a:solidFill>
-                <a:latin typeface="Calibri"/>
-              </a:rPr>
-              <a:t>vite-plugin-pwa (Workbox): install, offline, updates</a:t>
-            </a:r>
-          </a:p>
         </p:txBody>
       </p:sp>
       <p:sp>
@@ -10008,7 +9989,7 @@
                 </a:solidFill>
                 <a:latin typeface="Calibri"/>
               </a:rPr>
-              <a:t>Production build checked in Chrome: offline, key encryption, backup</a:t>
+              <a:t>Production build checked in Chrome: key encryption, backup</a:t>
             </a:r>
           </a:p>
           <a:p>
@@ -11071,7 +11052,7 @@
                 </a:solidFill>
                 <a:latin typeface="Cambria"/>
               </a:rPr>
-              <a:t>Installable app, encrypted keys</a:t>
+              <a:t>Encrypted keys, backup and restore</a:t>
             </a:r>
           </a:p>
         </p:txBody>
@@ -11113,7 +11094,7 @@
                 </a:solidFill>
                 <a:latin typeface="Calibri"/>
               </a:rPr>
-              <a:t>Offline use, backup and restore, Gemini by default</a:t>
+              <a:t>Gemini by default, help built into the menu</a:t>
             </a:r>
           </a:p>
         </p:txBody>
@@ -11329,7 +11310,7 @@
                 </a:solidFill>
                 <a:latin typeface="Calibri"/>
               </a:rPr>
-              <a:t>Host on Vercel; Android app via PWABuilder</a:t>
+              <a:t>Host on Vercel - a free static site</a:t>
             </a:r>
           </a:p>
         </p:txBody>

</xml_diff>